<commit_message>
Designer: TpT 012 Bass & Melody Writing fix round 2 (QA round 1 fixes)
Page 14 step 4 V to I; page 4 one chord per measure; page 9 discloses the
A minor card line, V to I and chord length; deck slide 7 layout gap; bass
bar and song-credit wording. New --check items. Rebuilt PDF, deck, preview
images, ZIP.

Co-Authored-By: Claude Sonnet 5.5 <noreply@anthropic.com>
Claude-Session: https://claude.ai/code/session_01UETtbiEyzCWi3eoMXW2Vud
</commit_message>
<xml_diff>
--- a/tpt/012-dmp1-bass-melody-writing/bass-melody-writing-intro-deck.pptx
+++ b/tpt/012-dmp1-bass-melody-writing/bass-melody-writing-intro-deck.pptx
@@ -1083,7 +1083,7 @@
           <a:lstStyle/>
           <a:p>
             <a:r>
-              <a:t>One possible answer for the plan on the last slide, I–V–vi–IV in C major. Every measure starts on the chord's root. Measures 1 and 2 use one rhythm idea, measures 3 and 4 a second one, and the last note walks back toward C. One note at a time: no overlaps. It breathes: nothing busier than eighth notes.</a:t>
+              <a:t>One possible answer for the plan on the last slide, I–V–vi–IV in C major. Every measure starts on the chord's root. Measures 1 and 2 use one rhythm idea, measures 3 and 4 a second one, and the last note, G, leads back into the loop. One note at a time: no overlaps. It breathes: nothing busier than eighth notes.</a:t>
             </a:r>
           </a:p>
         </p:txBody>
@@ -12261,7 +12261,7 @@
                 </a:solidFill>
                 <a:latin typeface="Source Sans 3"/>
               </a:rPr>
-              <a:t>The last note walks back home</a:t>
+              <a:t>The last note leans into the next chord</a:t>
             </a:r>
           </a:p>
         </p:txBody>
@@ -21666,7 +21666,7 @@
         <p:spPr>
           <a:xfrm>
             <a:off x="548640" y="1810512"/>
-            <a:ext cx="5449824" cy="2029968"/>
+            <a:ext cx="5449824" cy="1828800"/>
           </a:xfrm>
           <a:prstGeom prst="roundRect">
             <a:avLst/>
@@ -21710,7 +21710,7 @@
         <p:spPr>
           <a:xfrm>
             <a:off x="548640" y="1883664"/>
-            <a:ext cx="5449824" cy="852586"/>
+            <a:ext cx="5449824" cy="768096"/>
           </a:xfrm>
           <a:prstGeom prst="rect">
             <a:avLst/>
@@ -21744,8 +21744,8 @@
         </p:nvSpPr>
         <p:spPr>
           <a:xfrm>
-            <a:off x="685800" y="2723997"/>
-            <a:ext cx="5175504" cy="1055583"/>
+            <a:off x="685800" y="2633472"/>
+            <a:ext cx="5175504" cy="950976"/>
           </a:xfrm>
           <a:prstGeom prst="rect">
             <a:avLst/>
@@ -21780,7 +21780,7 @@
         <p:spPr>
           <a:xfrm>
             <a:off x="6190488" y="1810512"/>
-            <a:ext cx="5449824" cy="2029968"/>
+            <a:ext cx="5449824" cy="1828800"/>
           </a:xfrm>
           <a:prstGeom prst="roundRect">
             <a:avLst/>
@@ -21824,7 +21824,7 @@
         <p:spPr>
           <a:xfrm>
             <a:off x="6190488" y="1883664"/>
-            <a:ext cx="5449824" cy="852586"/>
+            <a:ext cx="5449824" cy="768096"/>
           </a:xfrm>
           <a:prstGeom prst="rect">
             <a:avLst/>
@@ -21858,8 +21858,8 @@
         </p:nvSpPr>
         <p:spPr>
           <a:xfrm>
-            <a:off x="6327648" y="2723997"/>
-            <a:ext cx="5175504" cy="1055583"/>
+            <a:off x="6327648" y="2633472"/>
+            <a:ext cx="5175504" cy="950976"/>
           </a:xfrm>
           <a:prstGeom prst="rect">
             <a:avLst/>
@@ -21893,8 +21893,8 @@
         </p:nvSpPr>
         <p:spPr>
           <a:xfrm>
-            <a:off x="548640" y="4023360"/>
-            <a:ext cx="5449824" cy="2029968"/>
+            <a:off x="548640" y="3803904"/>
+            <a:ext cx="5449824" cy="1828800"/>
           </a:xfrm>
           <a:prstGeom prst="roundRect">
             <a:avLst/>
@@ -21937,8 +21937,8 @@
         </p:nvSpPr>
         <p:spPr>
           <a:xfrm>
-            <a:off x="548640" y="4096512"/>
-            <a:ext cx="5449824" cy="852586"/>
+            <a:off x="548640" y="3877056"/>
+            <a:ext cx="5449824" cy="768096"/>
           </a:xfrm>
           <a:prstGeom prst="rect">
             <a:avLst/>
@@ -21972,8 +21972,8 @@
         </p:nvSpPr>
         <p:spPr>
           <a:xfrm>
-            <a:off x="685800" y="4936845"/>
-            <a:ext cx="5175504" cy="1055583"/>
+            <a:off x="685800" y="4626864"/>
+            <a:ext cx="5175504" cy="950976"/>
           </a:xfrm>
           <a:prstGeom prst="rect">
             <a:avLst/>
@@ -22007,8 +22007,8 @@
         </p:nvSpPr>
         <p:spPr>
           <a:xfrm>
-            <a:off x="6190488" y="4023360"/>
-            <a:ext cx="5449824" cy="2029968"/>
+            <a:off x="6190488" y="3803904"/>
+            <a:ext cx="5449824" cy="1828800"/>
           </a:xfrm>
           <a:prstGeom prst="roundRect">
             <a:avLst/>
@@ -22051,8 +22051,8 @@
         </p:nvSpPr>
         <p:spPr>
           <a:xfrm>
-            <a:off x="6190488" y="4096512"/>
-            <a:ext cx="5449824" cy="852586"/>
+            <a:off x="6190488" y="3877056"/>
+            <a:ext cx="5449824" cy="768096"/>
           </a:xfrm>
           <a:prstGeom prst="rect">
             <a:avLst/>
@@ -22086,8 +22086,8 @@
         </p:nvSpPr>
         <p:spPr>
           <a:xfrm>
-            <a:off x="6327648" y="4936845"/>
-            <a:ext cx="5175504" cy="1055583"/>
+            <a:off x="6327648" y="4626864"/>
+            <a:ext cx="5175504" cy="950976"/>
           </a:xfrm>
           <a:prstGeom prst="rect">
             <a:avLst/>
@@ -22121,7 +22121,7 @@
         </p:nvSpPr>
         <p:spPr>
           <a:xfrm>
-            <a:off x="548640" y="5989320"/>
+            <a:off x="548640" y="5870448"/>
             <a:ext cx="11064240" cy="365760"/>
           </a:xfrm>
           <a:prstGeom prst="rect">

</xml_diff>